<commit_message>
Resolved issue with Later Afternoon option and some changes to data choices
</commit_message>
<xml_diff>
--- a/Templates/Childrens_Party_Invite_Template_v2.pptx
+++ b/Templates/Childrens_Party_Invite_Template_v2.pptx
@@ -131,7 +131,7 @@
   <pc:docChgLst>
     <pc:chgData name="Shane Gillespie [C]" userId="23d9c95d-eff8-40ff-a6f7-25a555eaf29f" providerId="ADAL" clId="{7D7DDF8E-BCA7-4ECD-995F-18AB804B7D32}"/>
     <pc:docChg chg="undo custSel addSld delSld modSld modMainMaster modNotesMaster">
-      <pc:chgData name="Shane Gillespie [C]" userId="23d9c95d-eff8-40ff-a6f7-25a555eaf29f" providerId="ADAL" clId="{7D7DDF8E-BCA7-4ECD-995F-18AB804B7D32}" dt="2025-12-11T12:21:16.861" v="156" actId="20577"/>
+      <pc:chgData name="Shane Gillespie [C]" userId="23d9c95d-eff8-40ff-a6f7-25a555eaf29f" providerId="ADAL" clId="{7D7DDF8E-BCA7-4ECD-995F-18AB804B7D32}" dt="2025-12-11T14:11:34.827" v="158" actId="1076"/>
       <pc:docMkLst>
         <pc:docMk/>
       </pc:docMkLst>
@@ -157,7 +157,7 @@
         </pc:sldMkLst>
       </pc:sldChg>
       <pc:sldChg chg="addSp modSp add mod">
-        <pc:chgData name="Shane Gillespie [C]" userId="23d9c95d-eff8-40ff-a6f7-25a555eaf29f" providerId="ADAL" clId="{7D7DDF8E-BCA7-4ECD-995F-18AB804B7D32}" dt="2025-12-11T12:21:16.861" v="156" actId="20577"/>
+        <pc:chgData name="Shane Gillespie [C]" userId="23d9c95d-eff8-40ff-a6f7-25a555eaf29f" providerId="ADAL" clId="{7D7DDF8E-BCA7-4ECD-995F-18AB804B7D32}" dt="2025-12-11T14:11:34.827" v="158" actId="1076"/>
         <pc:sldMkLst>
           <pc:docMk/>
           <pc:sldMk cId="1102402849" sldId="261"/>
@@ -179,7 +179,7 @@
           </ac:spMkLst>
         </pc:spChg>
         <pc:spChg chg="mod">
-          <ac:chgData name="Shane Gillespie [C]" userId="23d9c95d-eff8-40ff-a6f7-25a555eaf29f" providerId="ADAL" clId="{7D7DDF8E-BCA7-4ECD-995F-18AB804B7D32}" dt="2025-12-11T12:21:16.861" v="156" actId="20577"/>
+          <ac:chgData name="Shane Gillespie [C]" userId="23d9c95d-eff8-40ff-a6f7-25a555eaf29f" providerId="ADAL" clId="{7D7DDF8E-BCA7-4ECD-995F-18AB804B7D32}" dt="2025-12-11T14:11:34.827" v="158" actId="1076"/>
           <ac:spMkLst>
             <pc:docMk/>
             <pc:sldMk cId="1102402849" sldId="261"/>
@@ -3489,8 +3489,8 @@
         </p:nvSpPr>
         <p:spPr>
           <a:xfrm>
-            <a:off x="0" y="1187089"/>
-            <a:ext cx="5246770" cy="5016758"/>
+            <a:off x="0" y="1001700"/>
+            <a:ext cx="5246770" cy="5509200"/>
           </a:xfrm>
           <a:prstGeom prst="rect">
             <a:avLst/>
@@ -3544,17 +3544,16 @@
               <a:rPr lang="en-IE" altLang="en-US" sz="3200" dirty="0">
                 <a:latin typeface="Monotype Corsiva" panose="03010101010201010101" pitchFamily="66" charset="0"/>
               </a:rPr>
-              <a:t>I am delighted to invite {{NAMES}} to meet me at the Coca-Cola Ballina Children’s Christmas Party, in The Diamond Coast Hotel on Sunday December 21, 2025 </a:t>
-            </a:r>
-            <a:r>
-              <a:rPr lang="en-IE" altLang="en-US" sz="3200">
+              <a:t>I am delighted to invite {{NAMES}} to meet me at the Coca-Cola Ballina Children’s Christmas Party, </a:t>
+            </a:r>
+          </a:p>
+          <a:p>
+            <a:r>
+              <a:rPr lang="en-IE" altLang="en-US" sz="3200" dirty="0">
                 <a:latin typeface="Monotype Corsiva" panose="03010101010201010101" pitchFamily="66" charset="0"/>
               </a:rPr>
-              <a:t>at {{TIME}}</a:t>
-            </a:r>
-            <a:endParaRPr lang="en-IE" altLang="en-US" sz="3200" dirty="0">
-              <a:latin typeface="Monotype Corsiva" panose="03010101010201010101" pitchFamily="66" charset="0"/>
-            </a:endParaRPr>
+              <a:t>in The Diamond Coast Hotel on Sunday December 21, 2025 at {{TIME}}</a:t>
+            </a:r>
           </a:p>
           <a:p>
             <a:r>

</xml_diff>